<commit_message>
Popuni uporednu tabelu performansi i dodaj tehnicki izvestaj i prezentaciju za Kafka stranu
- Zameni 'kolega' placeholdere u generate.py realnim Kafka brojevima (Scenario A/D)
- Popuni MQTT tabelu performansi u Plan.md (Scenario A)
- Dodaj izvestaj.md: opis sistema, rezultati A-D, uporedna tabela, odgovori na kriticna pitanja
- Dodaj kafka/presentation: standalone prezentacija sa grafikonima za Kafka stranu
</commit_message>
<xml_diff>
--- a/mqtt/presentation/prezentacija.pptx
+++ b/mqtt/presentation/prezentacija.pptx
@@ -5349,7 +5349,7 @@
                   <a:srgbClr val="000000"/>
                 </a:solidFill>
               </a:rPr>
-              <a:t>kolega</a:t>
+              <a:t>264k msg/s</a:t>
             </a:r>
           </a:p>
         </p:txBody>
@@ -5382,7 +5382,7 @@
                   <a:srgbClr val="000000"/>
                 </a:solidFill>
               </a:rPr>
-              <a:t>kolega</a:t>
+              <a:t>~10 ms*</a:t>
             </a:r>
           </a:p>
         </p:txBody>
@@ -5415,7 +5415,7 @@
                   <a:srgbClr val="000000"/>
                 </a:solidFill>
               </a:rPr>
-              <a:t>kolega</a:t>
+              <a:t>104%</a:t>
             </a:r>
           </a:p>
         </p:txBody>
@@ -5448,7 +5448,7 @@
                   <a:srgbClr val="000000"/>
                 </a:solidFill>
               </a:rPr>
-              <a:t>~512 MB+</a:t>
+              <a:t>~1.1 GB</a:t>
             </a:r>
           </a:p>
         </p:txBody>
@@ -5514,7 +5514,7 @@
                   <a:srgbClr val="000000"/>
                 </a:solidFill>
               </a:rPr>
-              <a:t>kolega</a:t>
+              <a:t>246k msg/s</a:t>
             </a:r>
           </a:p>
         </p:txBody>
@@ -5547,7 +5547,7 @@
                   <a:srgbClr val="000000"/>
                 </a:solidFill>
               </a:rPr>
-              <a:t>kolega</a:t>
+              <a:t>~10 ms*</a:t>
             </a:r>
           </a:p>
         </p:txBody>
@@ -5580,7 +5580,7 @@
                   <a:srgbClr val="000000"/>
                 </a:solidFill>
               </a:rPr>
-              <a:t>kolega</a:t>
+              <a:t>17%</a:t>
             </a:r>
           </a:p>
         </p:txBody>
@@ -5613,7 +5613,41 @@
                   <a:srgbClr val="000000"/>
                 </a:solidFill>
               </a:rPr>
-              <a:t>~512 MB+</a:t>
+              <a:t>~1.2 GB</a:t>
+            </a:r>
+          </a:p>
+        </p:txBody>
+      </p:sp>
+      <p:sp>
+        <p:nvSpPr>
+          <p:cNvPr id="33" name="TextBox 32"/>
+          <p:cNvSpPr txBox="1"/>
+          <p:nvPr/>
+        </p:nvSpPr>
+        <p:spPr>
+          <a:xfrm>
+            <a:off x="274320" y="3730752"/>
+            <a:ext cx="8412480" cy="548640"/>
+          </a:xfrm>
+          <a:prstGeom prst="rect">
+            <a:avLst/>
+          </a:prstGeom>
+          <a:noFill/>
+        </p:spPr>
+        <p:txBody>
+          <a:bodyPr wrap="square">
+            <a:spAutoFit/>
+          </a:bodyPr>
+          <a:lstStyle/>
+          <a:p>
+            <a:pPr algn="l"/>
+            <a:r>
+              <a:rPr sz="800" b="0">
+                <a:solidFill>
+                  <a:srgbClr val="666666"/>
+                </a:solidFill>
+              </a:rPr>
+              <a:t>* p95 latencija merena u Scenariju D (acks=1, RF=1) — acks nivo ne menja trenutak upisa poruke u broker log, vec samo producer-side confirmation (utice na throughput/loss, vidi Scenario A).</a:t>
             </a:r>
           </a:p>
         </p:txBody>

</xml_diff>